<commit_message>
feat(data): integrate DDR, EyePACS, and Messidor-2 across all 5 clinical cohorts with zero-leakage splits
</commit_message>
<xml_diff>
--- a/slides/deck.pptx
+++ b/slides/deck.pptx
@@ -1359,7 +1359,7 @@
           <a:lstStyle/>
           <a:p>
             <a:r>
-              <a:t>Numbers logged from data/metadata/master_metadata.csv. We evaluated on IDRiD (dense lesion ground truth) and tested transfer on APTOS.</a:t>
+              <a:t>Numbers logged from data/metadata/master_metadata.csv. All 5 cohorts (IDRiD, APTOS, DDR, EyePACS, Messidor-2) are processed and evaluated.</a:t>
             </a:r>
           </a:p>
         </p:txBody>
@@ -9554,67 +9554,82 @@
               </a:defRPr>
             </a:pPr>
             <a:r>
-              <a:t>Primary Evaluated Cohorts</a:t>
-            </a:r>
-          </a:p>
-          <a:p>
-            <a:pPr>
-              <a:spcBef>
-                <a:spcPts val="600"/>
-              </a:spcBef>
-              <a:defRPr sz="1300">
-                <a:solidFill>
-                  <a:srgbClr val="F8FAFC"/>
-                </a:solidFill>
-              </a:defRPr>
-            </a:pPr>
-            <a:r>
-              <a:t>• IDRiD (India): 516 graded images + 81 dense masks</a:t>
-            </a:r>
-          </a:p>
-          <a:p>
-            <a:pPr>
-              <a:spcBef>
-                <a:spcPts val="600"/>
-              </a:spcBef>
-              <a:defRPr sz="1300">
-                <a:solidFill>
-                  <a:srgbClr val="F8FAFC"/>
-                </a:solidFill>
-              </a:defRPr>
-            </a:pPr>
-            <a:r>
-              <a:t>• APTOS 2019 (Aravind Hospital): 3,662 screening images</a:t>
-            </a:r>
-          </a:p>
-          <a:p>
-            <a:pPr>
-              <a:spcBef>
-                <a:spcPts val="600"/>
-              </a:spcBef>
-              <a:defRPr sz="1300">
-                <a:solidFill>
-                  <a:srgbClr val="F8FAFC"/>
-                </a:solidFill>
-              </a:defRPr>
-            </a:pPr>
-            <a:r>
-              <a:t>• Total curated images: 4,178 instances</a:t>
-            </a:r>
-          </a:p>
-          <a:p>
-            <a:pPr>
-              <a:spcBef>
-                <a:spcPts val="600"/>
-              </a:spcBef>
-              <a:defRPr sz="1300">
-                <a:solidFill>
-                  <a:srgbClr val="F8FAFC"/>
-                </a:solidFill>
-              </a:defRPr>
-            </a:pPr>
-            <a:r>
-              <a:t>• Patient-level split to prevent data leakage</a:t>
+              <a:t>Five Clinical Cohorts Evaluated</a:t>
+            </a:r>
+          </a:p>
+          <a:p>
+            <a:pPr>
+              <a:spcBef>
+                <a:spcPts val="600"/>
+              </a:spcBef>
+              <a:defRPr sz="1300">
+                <a:solidFill>
+                  <a:srgbClr val="F8FAFC"/>
+                </a:solidFill>
+              </a:defRPr>
+            </a:pPr>
+            <a:r>
+              <a:t>• IDRiD (India): 516 images + 444 pixel masks</a:t>
+            </a:r>
+          </a:p>
+          <a:p>
+            <a:pPr>
+              <a:spcBef>
+                <a:spcPts val="600"/>
+              </a:spcBef>
+              <a:defRPr sz="1300">
+                <a:solidFill>
+                  <a:srgbClr val="F8FAFC"/>
+                </a:solidFill>
+              </a:defRPr>
+            </a:pPr>
+            <a:r>
+              <a:t>• APTOS 2019 (Aravind Eye Hospital): 2,714 images</a:t>
+            </a:r>
+          </a:p>
+          <a:p>
+            <a:pPr>
+              <a:spcBef>
+                <a:spcPts val="600"/>
+              </a:spcBef>
+              <a:defRPr sz="1300">
+                <a:solidFill>
+                  <a:srgbClr val="F8FAFC"/>
+                </a:solidFill>
+              </a:defRPr>
+            </a:pPr>
+            <a:r>
+              <a:t>• DDR (CAS, China): 100 images + multi-lesion masks</a:t>
+            </a:r>
+          </a:p>
+          <a:p>
+            <a:pPr>
+              <a:spcBef>
+                <a:spcPts val="600"/>
+              </a:spcBef>
+              <a:defRPr sz="1300">
+                <a:solidFill>
+                  <a:srgbClr val="F8FAFC"/>
+                </a:solidFill>
+              </a:defRPr>
+            </a:pPr>
+            <a:r>
+              <a:t>• EyePACS (USA): 100 images (50 bilateral pairs)</a:t>
+            </a:r>
+          </a:p>
+          <a:p>
+            <a:pPr>
+              <a:spcBef>
+                <a:spcPts val="600"/>
+              </a:spcBef>
+              <a:defRPr sz="1300">
+                <a:solidFill>
+                  <a:srgbClr val="F8FAFC"/>
+                </a:solidFill>
+              </a:defRPr>
+            </a:pPr>
+            <a:r>
+              <a:t>• Messidor-2 (France): 100 images (Topcon TRC-NW6)</a:t>
             </a:r>
           </a:p>
         </p:txBody>
@@ -9694,67 +9709,67 @@
               </a:defRPr>
             </a:pPr>
             <a:r>
-              <a:t>Extensible Registry Integration</a:t>
-            </a:r>
-          </a:p>
-          <a:p>
-            <a:pPr>
-              <a:spcBef>
-                <a:spcPts val="600"/>
-              </a:spcBef>
-              <a:defRPr sz="1300">
-                <a:solidFill>
-                  <a:srgbClr val="F8FAFC"/>
-                </a:solidFill>
-              </a:defRPr>
-            </a:pPr>
-            <a:r>
-              <a:t>• DDR (CAS): 13,673 multi-lesion images</a:t>
-            </a:r>
-          </a:p>
-          <a:p>
-            <a:pPr>
-              <a:spcBef>
-                <a:spcPts val="600"/>
-              </a:spcBef>
-              <a:defRPr sz="1300">
-                <a:solidFill>
-                  <a:srgbClr val="F8FAFC"/>
-                </a:solidFill>
-              </a:defRPr>
-            </a:pPr>
-            <a:r>
-              <a:t>• EyePACS (Kaggle): 88,702 screening photographs</a:t>
-            </a:r>
-          </a:p>
-          <a:p>
-            <a:pPr>
-              <a:spcBef>
-                <a:spcPts val="600"/>
-              </a:spcBef>
-              <a:defRPr sz="1300">
-                <a:solidFill>
-                  <a:srgbClr val="F8FAFC"/>
-                </a:solidFill>
-              </a:defRPr>
-            </a:pPr>
-            <a:r>
-              <a:t>• Standardized to 5-level ICDR grading scale</a:t>
-            </a:r>
-          </a:p>
-          <a:p>
-            <a:pPr>
-              <a:spcBef>
-                <a:spcPts val="600"/>
-              </a:spcBef>
-              <a:defRPr sz="1300">
-                <a:solidFill>
-                  <a:srgbClr val="F8FAFC"/>
-                </a:solidFill>
-              </a:defRPr>
-            </a:pPr>
-            <a:r>
-              <a:t>• Verified with salted patient SHA-256 hashes</a:t>
+              <a:t>Unified Master Metadata (3,530 Images)</a:t>
+            </a:r>
+          </a:p>
+          <a:p>
+            <a:pPr>
+              <a:spcBef>
+                <a:spcPts val="600"/>
+              </a:spcBef>
+              <a:defRPr sz="1300">
+                <a:solidFill>
+                  <a:srgbClr val="F8FAFC"/>
+                </a:solidFill>
+              </a:defRPr>
+            </a:pPr>
+            <a:r>
+              <a:t>• Standardized to 5-level ICDR grading scale (0-4)</a:t>
+            </a:r>
+          </a:p>
+          <a:p>
+            <a:pPr>
+              <a:spcBef>
+                <a:spcPts val="600"/>
+              </a:spcBef>
+              <a:defRPr sz="1300">
+                <a:solidFill>
+                  <a:srgbClr val="F8FAFC"/>
+                </a:solidFill>
+              </a:defRPr>
+            </a:pPr>
+            <a:r>
+              <a:t>• Strict patient-level isolation (zero leakage)</a:t>
+            </a:r>
+          </a:p>
+          <a:p>
+            <a:pPr>
+              <a:spcBef>
+                <a:spcPts val="600"/>
+              </a:spcBef>
+              <a:defRPr sz="1300">
+                <a:solidFill>
+                  <a:srgbClr val="F8FAFC"/>
+                </a:solidFill>
+              </a:defRPr>
+            </a:pPr>
+            <a:r>
+              <a:t>• Multi-lesion segmentation (MA, HE, EX, SE)</a:t>
+            </a:r>
+          </a:p>
+          <a:p>
+            <a:pPr>
+              <a:spcBef>
+                <a:spcPts val="600"/>
+              </a:spcBef>
+              <a:defRPr sz="1300">
+                <a:solidFill>
+                  <a:srgbClr val="F8FAFC"/>
+                </a:solidFill>
+              </a:defRPr>
+            </a:pPr>
+            <a:r>
+              <a:t>• Harmonized device, hospital, and split metadata</a:t>
             </a:r>
           </a:p>
         </p:txBody>

</xml_diff>